<commit_message>
chore: updated report, PPTX, handover with final 19-module metrics and regenerated all downloadable deliverables
</commit_message>
<xml_diff>
--- a/deliverables/SIARM-Defense.pptx
+++ b/deliverables/SIARM-Defense.pptx
@@ -9876,7 +9876,7 @@
                 <a:ea typeface="Calibri" pitchFamily="34" charset="-122"/>
                 <a:cs typeface="Calibri" pitchFamily="34" charset="-120"/>
               </a:rPr>
-              <a:t>50</a:t>
+              <a:t>52</a:t>
             </a:r>
             <a:endParaRPr lang="en-US" sz="3600" dirty="0"/>
           </a:p>
@@ -9981,7 +9981,7 @@
                 <a:ea typeface="Calibri" pitchFamily="34" charset="-122"/>
                 <a:cs typeface="Calibri" pitchFamily="34" charset="-120"/>
               </a:rPr>
-              <a:t>8,800</a:t>
+              <a:t>9,200</a:t>
             </a:r>
             <a:endParaRPr lang="en-US" sz="3600" dirty="0"/>
           </a:p>
@@ -10086,7 +10086,7 @@
                 <a:ea typeface="Calibri" pitchFamily="34" charset="-122"/>
                 <a:cs typeface="Calibri" pitchFamily="34" charset="-120"/>
               </a:rPr>
-              <a:t>22</a:t>
+              <a:t>24</a:t>
             </a:r>
             <a:endParaRPr lang="en-US" sz="3600" dirty="0"/>
           </a:p>
@@ -10191,7 +10191,7 @@
                 <a:ea typeface="Calibri" pitchFamily="34" charset="-122"/>
                 <a:cs typeface="Calibri" pitchFamily="34" charset="-120"/>
               </a:rPr>
-              <a:t>15</a:t>
+              <a:t>19</a:t>
             </a:r>
             <a:endParaRPr lang="en-US" sz="3600" dirty="0"/>
           </a:p>
@@ -10296,7 +10296,7 @@
                 <a:ea typeface="Calibri" pitchFamily="34" charset="-122"/>
                 <a:cs typeface="Calibri" pitchFamily="34" charset="-120"/>
               </a:rPr>
-              <a:t>12</a:t>
+              <a:t>14</a:t>
             </a:r>
             <a:endParaRPr lang="en-US" sz="3600" dirty="0"/>
           </a:p>
@@ -10506,7 +10506,7 @@
                 <a:ea typeface="Calibri" pitchFamily="34" charset="-122"/>
                 <a:cs typeface="Calibri" pitchFamily="34" charset="-120"/>
               </a:rPr>
-              <a:t>464 kB</a:t>
+              <a:t>478 kB</a:t>
             </a:r>
             <a:endParaRPr lang="en-US" sz="3600" dirty="0"/>
           </a:p>
@@ -14584,7 +14584,7 @@
                 <a:ea typeface="Calibri" pitchFamily="34" charset="-122"/>
                 <a:cs typeface="Calibri" pitchFamily="34" charset="-120"/>
               </a:rPr>
-              <a:t>Functional completeness — all 15 modules navigable</a:t>
+              <a:t>Functional completeness — all 19 modules navigable</a:t>
             </a:r>
             <a:endParaRPr lang="en-US" sz="1400" dirty="0"/>
           </a:p>

</xml_diff>